<commit_message>
Add markdown one-pager and regenerate showcase PPT
</commit_message>
<xml_diff>
--- a/Expo_Showcase_Presentation.pptx
+++ b/Expo_Showcase_Presentation.pptx
@@ -10,8 +10,9 @@
     <p:sldId id="258" r:id="rId9"/>
     <p:sldId id="259" r:id="rId10"/>
     <p:sldId id="260" r:id="rId11"/>
+    <p:sldId id="261" r:id="rId12"/>
   </p:sldIdLst>
-  <p:sldSz cx="12191695" cy="6858000" type="screen4x3"/>
+  <p:sldSz cx="9144000" cy="6858000" type="screen4x3"/>
   <p:notesSz cx="6858000" cy="9144000"/>
   <p:defaultTextStyle>
     <a:defPPr>
@@ -3085,14 +3086,6 @@
 <file path=ppt/slides/slide1.xml><?xml version="1.0" encoding="utf-8"?>
 <p:sld xmlns:a="http://schemas.openxmlformats.org/drawingml/2006/main" xmlns:p="http://schemas.openxmlformats.org/presentationml/2006/main" xmlns:r="http://schemas.openxmlformats.org/officeDocument/2006/relationships">
   <p:cSld>
-    <p:bg>
-      <p:bgPr>
-        <a:solidFill>
-          <a:srgbClr val="0F172A"/>
-        </a:solidFill>
-        <a:effectLst/>
-      </p:bgPr>
-    </p:bg>
     <p:spTree>
       <p:nvGrpSpPr>
         <p:cNvPr id="1" name=""/>
@@ -3102,14 +3095,57 @@
       <p:grpSpPr/>
       <p:sp>
         <p:nvSpPr>
-          <p:cNvPr id="2" name="TextBox 1"/>
+          <p:cNvPr id="2" name="Rectangle 1"/>
+          <p:cNvSpPr/>
+          <p:nvPr/>
+        </p:nvSpPr>
+        <p:spPr>
+          <a:xfrm>
+            <a:off x="0" y="0"/>
+            <a:ext cx="12191695" cy="6858000"/>
+          </a:xfrm>
+          <a:prstGeom prst="rect">
+            <a:avLst/>
+          </a:prstGeom>
+          <a:solidFill>
+            <a:srgbClr val="0D1B2A"/>
+          </a:solidFill>
+          <a:ln>
+            <a:noFill/>
+          </a:ln>
+        </p:spPr>
+        <p:style>
+          <a:lnRef idx="1">
+            <a:schemeClr val="accent1"/>
+          </a:lnRef>
+          <a:fillRef idx="3">
+            <a:schemeClr val="accent1"/>
+          </a:fillRef>
+          <a:effectRef idx="2">
+            <a:schemeClr val="accent1"/>
+          </a:effectRef>
+          <a:fontRef idx="minor">
+            <a:schemeClr val="lt1"/>
+          </a:fontRef>
+        </p:style>
+        <p:txBody>
+          <a:bodyPr rtlCol="0" anchor="ctr"/>
+          <a:lstStyle/>
+          <a:p>
+            <a:pPr algn="ctr"/>
+          </a:p>
+        </p:txBody>
+      </p:sp>
+      <p:sp>
+        <p:nvSpPr>
+          <p:cNvPr id="3" name="TextBox 2"/>
           <p:cNvSpPr txBox="1"/>
           <p:nvPr/>
         </p:nvSpPr>
         <p:spPr>
           <a:xfrm>
-            <a:off x="457200" y="228600"/>
-            <a:ext cx="11247120" cy="822960"/>
+            <a:off x="731520" y="1280160"/>
+            <a:ext cx="10789920" cy="3200400"/>
           </a:xfrm>
           <a:prstGeom prst="rect">
             <a:avLst/>
@@ -3123,42 +3159,33 @@
           <a:lstStyle/>
           <a:p>
             <a:pPr>
-              <a:defRPr sz="3600" b="1">
+              <a:defRPr sz="4000" b="1">
                 <a:solidFill>
-                  <a:srgbClr val="22D3EE"/>
+                  <a:srgbClr val="FFFFFF"/>
                 </a:solidFill>
               </a:defRPr>
             </a:pPr>
             <a:r>
-              <a:t>🔋 Key-Off Load / NM Wake Diagnostic Tool</a:t>
-            </a:r>
-          </a:p>
-        </p:txBody>
-      </p:sp>
-      <p:pic>
-        <p:nvPicPr>
-          <p:cNvPr id="3" name="Picture 2" descr="problem_visual.png"/>
-          <p:cNvPicPr>
-            <a:picLocks noChangeAspect="1"/>
-          </p:cNvPicPr>
-          <p:nvPr/>
-        </p:nvPicPr>
-        <p:blipFill>
-          <a:blip r:embed="rId2"/>
-          <a:stretch>
-            <a:fillRect/>
-          </a:stretch>
-        </p:blipFill>
-        <p:spPr>
-          <a:xfrm>
-            <a:off x="822960" y="1188720"/>
-            <a:ext cx="10515600" cy="5303520"/>
-          </a:xfrm>
-          <a:prstGeom prst="rect">
-            <a:avLst/>
-          </a:prstGeom>
-        </p:spPr>
-      </p:pic>
+              <a:t>Key-Off Load / NM Wake Diagnostic Tool</a:t>
+            </a:r>
+          </a:p>
+          <a:p>
+            <a:pPr>
+              <a:spcBef>
+                <a:spcPts val="1800"/>
+              </a:spcBef>
+              <a:defRPr sz="2000">
+                <a:solidFill>
+                  <a:srgbClr val="BED2E6"/>
+                </a:solidFill>
+              </a:defRPr>
+            </a:pPr>
+            <a:r>
+              <a:t>Automated detection of ECUs causing post key-off battery drain</a:t>
+            </a:r>
+          </a:p>
+        </p:txBody>
+      </p:sp>
     </p:spTree>
   </p:cSld>
   <p:clrMapOvr>
@@ -3170,14 +3197,6 @@
 <file path=ppt/slides/slide2.xml><?xml version="1.0" encoding="utf-8"?>
 <p:sld xmlns:a="http://schemas.openxmlformats.org/drawingml/2006/main" xmlns:p="http://schemas.openxmlformats.org/presentationml/2006/main" xmlns:r="http://schemas.openxmlformats.org/officeDocument/2006/relationships">
   <p:cSld>
-    <p:bg>
-      <p:bgPr>
-        <a:solidFill>
-          <a:srgbClr val="111827"/>
-        </a:solidFill>
-        <a:effectLst/>
-      </p:bgPr>
-    </p:bg>
     <p:spTree>
       <p:nvGrpSpPr>
         <p:cNvPr id="1" name=""/>
@@ -3187,14 +3206,57 @@
       <p:grpSpPr/>
       <p:sp>
         <p:nvSpPr>
-          <p:cNvPr id="2" name="TextBox 1"/>
+          <p:cNvPr id="2" name="Rectangle 1"/>
+          <p:cNvSpPr/>
+          <p:nvPr/>
+        </p:nvSpPr>
+        <p:spPr>
+          <a:xfrm>
+            <a:off x="0" y="0"/>
+            <a:ext cx="12191695" cy="1005840"/>
+          </a:xfrm>
+          <a:prstGeom prst="rect">
+            <a:avLst/>
+          </a:prstGeom>
+          <a:solidFill>
+            <a:srgbClr val="0D1B2A"/>
+          </a:solidFill>
+          <a:ln>
+            <a:noFill/>
+          </a:ln>
+        </p:spPr>
+        <p:style>
+          <a:lnRef idx="1">
+            <a:schemeClr val="accent1"/>
+          </a:lnRef>
+          <a:fillRef idx="3">
+            <a:schemeClr val="accent1"/>
+          </a:fillRef>
+          <a:effectRef idx="2">
+            <a:schemeClr val="accent1"/>
+          </a:effectRef>
+          <a:fontRef idx="minor">
+            <a:schemeClr val="lt1"/>
+          </a:fontRef>
+        </p:style>
+        <p:txBody>
+          <a:bodyPr rtlCol="0" anchor="ctr"/>
+          <a:lstStyle/>
+          <a:p>
+            <a:pPr algn="ctr"/>
+          </a:p>
+        </p:txBody>
+      </p:sp>
+      <p:sp>
+        <p:nvSpPr>
+          <p:cNvPr id="3" name="TextBox 2"/>
           <p:cNvSpPr txBox="1"/>
           <p:nvPr/>
         </p:nvSpPr>
         <p:spPr>
           <a:xfrm>
-            <a:off x="457200" y="228600"/>
-            <a:ext cx="11247120" cy="822960"/>
+            <a:off x="548640" y="228600"/>
+            <a:ext cx="11155680" cy="548640"/>
           </a:xfrm>
           <a:prstGeom prst="rect">
             <a:avLst/>
@@ -3208,28 +3270,28 @@
           <a:lstStyle/>
           <a:p>
             <a:pPr>
-              <a:defRPr sz="3600" b="1">
+              <a:defRPr sz="2800" b="1">
                 <a:solidFill>
-                  <a:srgbClr val="F472B6"/>
+                  <a:srgbClr val="FFFFFF"/>
                 </a:solidFill>
               </a:defRPr>
             </a:pPr>
             <a:r>
-              <a:t>1) What is the Problem?</a:t>
-            </a:r>
-          </a:p>
-        </p:txBody>
-      </p:sp>
-      <p:sp>
-        <p:nvSpPr>
-          <p:cNvPr id="3" name="TextBox 2"/>
+              <a:t>Problem and Impact</a:t>
+            </a:r>
+          </a:p>
+        </p:txBody>
+      </p:sp>
+      <p:sp>
+        <p:nvSpPr>
+          <p:cNvPr id="4" name="TextBox 3"/>
           <p:cNvSpPr txBox="1"/>
           <p:nvPr/>
         </p:nvSpPr>
         <p:spPr>
           <a:xfrm>
-            <a:off x="640080" y="1280160"/>
-            <a:ext cx="5669280" cy="5029200"/>
+            <a:off x="822960" y="1280160"/>
+            <a:ext cx="10789920" cy="5120640"/>
           </a:xfrm>
           <a:prstGeom prst="rect">
             <a:avLst/>
@@ -3237,96 +3299,57 @@
           <a:noFill/>
         </p:spPr>
         <p:txBody>
-          <a:bodyPr wrap="none">
+          <a:bodyPr wrap="square">
             <a:spAutoFit/>
           </a:bodyPr>
           <a:lstStyle/>
           <a:p>
             <a:pPr>
-              <a:defRPr sz="2400">
+              <a:spcAft>
+                <a:spcPts val="1400"/>
+              </a:spcAft>
+              <a:defRPr sz="2200">
                 <a:solidFill>
-                  <a:srgbClr val="E5E7EB"/>
+                  <a:srgbClr val="465462"/>
                 </a:solidFill>
               </a:defRPr>
             </a:pPr>
             <a:r>
-              <a:t>• Some ECUs fail to enter sleep mode after key-off</a:t>
+              <a:t>ECUs remaining active after key-off can prevent CAN sleep and drain battery capacity.</a:t>
             </a:r>
           </a:p>
           <a:p>
             <a:pPr>
-              <a:defRPr sz="2400">
+              <a:spcAft>
+                <a:spcPts val="1400"/>
+              </a:spcAft>
+              <a:defRPr sz="2200">
                 <a:solidFill>
-                  <a:srgbClr val="E5E7EB"/>
+                  <a:srgbClr val="465462"/>
                 </a:solidFill>
               </a:defRPr>
             </a:pPr>
             <a:r>
-              <a:t>• CAN Network Management messages continue unnecessarily</a:t>
+              <a:t>Late sleep and stuck-awake nodes drive repeat diagnostics and warranty escalation.</a:t>
             </a:r>
           </a:p>
           <a:p>
             <a:pPr>
-              <a:defRPr sz="2400">
+              <a:spcAft>
+                <a:spcPts val="1400"/>
+              </a:spcAft>
+              <a:defRPr sz="2200">
                 <a:solidFill>
-                  <a:srgbClr val="E5E7EB"/>
+                  <a:srgbClr val="465462"/>
                 </a:solidFill>
               </a:defRPr>
             </a:pPr>
             <a:r>
-              <a:t>• Bus stays awake and causes parasitic battery drain</a:t>
-            </a:r>
-          </a:p>
-          <a:p>
-            <a:pPr>
-              <a:defRPr sz="2400">
-                <a:solidFill>
-                  <a:srgbClr val="E5E7EB"/>
-                </a:solidFill>
-              </a:defRPr>
-            </a:pPr>
-            <a:r>
-              <a:t>• Teams spend hours manually scanning logs</a:t>
-            </a:r>
-          </a:p>
-          <a:p>
-            <a:pPr>
-              <a:defRPr sz="2400">
-                <a:solidFill>
-                  <a:srgbClr val="E5E7EB"/>
-                </a:solidFill>
-              </a:defRPr>
-            </a:pPr>
-            <a:r>
-              <a:t>• Field impact: dead battery complaints and warranty claims</a:t>
-            </a:r>
-          </a:p>
-        </p:txBody>
-      </p:sp>
-      <p:pic>
-        <p:nvPicPr>
-          <p:cNvPr id="4" name="Picture 3" descr="problem_visual.png"/>
-          <p:cNvPicPr>
-            <a:picLocks noChangeAspect="1"/>
-          </p:cNvPicPr>
-          <p:nvPr/>
-        </p:nvPicPr>
-        <p:blipFill>
-          <a:blip r:embed="rId2"/>
-          <a:stretch>
-            <a:fillRect/>
-          </a:stretch>
-        </p:blipFill>
-        <p:spPr>
-          <a:xfrm>
-            <a:off x="6492240" y="1371600"/>
-            <a:ext cx="5029200" cy="4480560"/>
-          </a:xfrm>
-          <a:prstGeom prst="rect">
-            <a:avLst/>
-          </a:prstGeom>
-        </p:spPr>
-      </p:pic>
+              <a:t>Manual analysis of large traces is slow and inconsistent across teams.</a:t>
+            </a:r>
+          </a:p>
+        </p:txBody>
+      </p:sp>
     </p:spTree>
   </p:cSld>
   <p:clrMapOvr>
@@ -3338,14 +3361,6 @@
 <file path=ppt/slides/slide3.xml><?xml version="1.0" encoding="utf-8"?>
 <p:sld xmlns:a="http://schemas.openxmlformats.org/drawingml/2006/main" xmlns:p="http://schemas.openxmlformats.org/presentationml/2006/main" xmlns:r="http://schemas.openxmlformats.org/officeDocument/2006/relationships">
   <p:cSld>
-    <p:bg>
-      <p:bgPr>
-        <a:solidFill>
-          <a:srgbClr val="052E16"/>
-        </a:solidFill>
-        <a:effectLst/>
-      </p:bgPr>
-    </p:bg>
     <p:spTree>
       <p:nvGrpSpPr>
         <p:cNvPr id="1" name=""/>
@@ -3355,14 +3370,57 @@
       <p:grpSpPr/>
       <p:sp>
         <p:nvSpPr>
-          <p:cNvPr id="2" name="TextBox 1"/>
+          <p:cNvPr id="2" name="Rectangle 1"/>
+          <p:cNvSpPr/>
+          <p:nvPr/>
+        </p:nvSpPr>
+        <p:spPr>
+          <a:xfrm>
+            <a:off x="0" y="0"/>
+            <a:ext cx="12191695" cy="1005840"/>
+          </a:xfrm>
+          <a:prstGeom prst="rect">
+            <a:avLst/>
+          </a:prstGeom>
+          <a:solidFill>
+            <a:srgbClr val="0D1B2A"/>
+          </a:solidFill>
+          <a:ln>
+            <a:noFill/>
+          </a:ln>
+        </p:spPr>
+        <p:style>
+          <a:lnRef idx="1">
+            <a:schemeClr val="accent1"/>
+          </a:lnRef>
+          <a:fillRef idx="3">
+            <a:schemeClr val="accent1"/>
+          </a:fillRef>
+          <a:effectRef idx="2">
+            <a:schemeClr val="accent1"/>
+          </a:effectRef>
+          <a:fontRef idx="minor">
+            <a:schemeClr val="lt1"/>
+          </a:fontRef>
+        </p:style>
+        <p:txBody>
+          <a:bodyPr rtlCol="0" anchor="ctr"/>
+          <a:lstStyle/>
+          <a:p>
+            <a:pPr algn="ctr"/>
+          </a:p>
+        </p:txBody>
+      </p:sp>
+      <p:sp>
+        <p:nvSpPr>
+          <p:cNvPr id="3" name="TextBox 2"/>
           <p:cNvSpPr txBox="1"/>
           <p:nvPr/>
         </p:nvSpPr>
         <p:spPr>
           <a:xfrm>
-            <a:off x="457200" y="228600"/>
-            <a:ext cx="11247120" cy="822960"/>
+            <a:off x="548640" y="228600"/>
+            <a:ext cx="11155680" cy="548640"/>
           </a:xfrm>
           <a:prstGeom prst="rect">
             <a:avLst/>
@@ -3376,28 +3434,28 @@
           <a:lstStyle/>
           <a:p>
             <a:pPr>
-              <a:defRPr sz="3600" b="1">
+              <a:defRPr sz="2800" b="1">
                 <a:solidFill>
-                  <a:srgbClr val="86EFAC"/>
+                  <a:srgbClr val="FFFFFF"/>
                 </a:solidFill>
               </a:defRPr>
             </a:pPr>
             <a:r>
-              <a:t>2) What Solution Do We Offer?</a:t>
-            </a:r>
-          </a:p>
-        </p:txBody>
-      </p:sp>
-      <p:sp>
-        <p:nvSpPr>
-          <p:cNvPr id="3" name="TextBox 2"/>
+              <a:t>Solution Summary</a:t>
+            </a:r>
+          </a:p>
+        </p:txBody>
+      </p:sp>
+      <p:sp>
+        <p:nvSpPr>
+          <p:cNvPr id="4" name="TextBox 3"/>
           <p:cNvSpPr txBox="1"/>
           <p:nvPr/>
         </p:nvSpPr>
         <p:spPr>
           <a:xfrm>
-            <a:off x="640080" y="1234440"/>
-            <a:ext cx="10972800" cy="1097280"/>
+            <a:off x="822960" y="1280160"/>
+            <a:ext cx="10789920" cy="5120640"/>
           </a:xfrm>
           <a:prstGeom prst="rect">
             <a:avLst/>
@@ -3405,48 +3463,57 @@
           <a:noFill/>
         </p:spPr>
         <p:txBody>
-          <a:bodyPr wrap="none">
+          <a:bodyPr wrap="square">
             <a:spAutoFit/>
           </a:bodyPr>
           <a:lstStyle/>
           <a:p>
             <a:pPr>
-              <a:defRPr sz="2400">
+              <a:spcAft>
+                <a:spcPts val="1400"/>
+              </a:spcAft>
+              <a:defRPr sz="2200">
                 <a:solidFill>
-                  <a:srgbClr val="DCFCE7"/>
+                  <a:srgbClr val="465462"/>
                 </a:solidFill>
               </a:defRPr>
             </a:pPr>
             <a:r>
-              <a:t>A browser-based diagnostic tool that automatically identifies ECUs causing key-off battery drain.</a:t>
-            </a:r>
-          </a:p>
-        </p:txBody>
-      </p:sp>
-      <p:pic>
-        <p:nvPicPr>
-          <p:cNvPr id="4" name="Picture 3" descr="solution_flow.png"/>
-          <p:cNvPicPr>
-            <a:picLocks noChangeAspect="1"/>
-          </p:cNvPicPr>
-          <p:nvPr/>
-        </p:nvPicPr>
-        <p:blipFill>
-          <a:blip r:embed="rId2"/>
-          <a:stretch>
-            <a:fillRect/>
-          </a:stretch>
-        </p:blipFill>
-        <p:spPr>
-          <a:xfrm>
-            <a:off x="731520" y="2011680"/>
-            <a:ext cx="10881360" cy="4389120"/>
-          </a:xfrm>
-          <a:prstGeom prst="rect">
-            <a:avLst/>
-          </a:prstGeom>
-        </p:spPr>
-      </p:pic>
+              <a:t>Automated ECU status classification: NORMAL, SLOW, VIOLATION, STUCK AWAKE.</a:t>
+            </a:r>
+          </a:p>
+          <a:p>
+            <a:pPr>
+              <a:spcAft>
+                <a:spcPts val="1400"/>
+              </a:spcAft>
+              <a:defRPr sz="2200">
+                <a:solidFill>
+                  <a:srgbClr val="465462"/>
+                </a:solidFill>
+              </a:defRPr>
+            </a:pPr>
+            <a:r>
+              <a:t>Per-ECU timeline with key-off reference for rapid evidence review.</a:t>
+            </a:r>
+          </a:p>
+          <a:p>
+            <a:pPr>
+              <a:spcAft>
+                <a:spcPts val="1400"/>
+              </a:spcAft>
+              <a:defRPr sz="2200">
+                <a:solidFill>
+                  <a:srgbClr val="465462"/>
+                </a:solidFill>
+              </a:defRPr>
+            </a:pPr>
+            <a:r>
+              <a:t>Configurable thresholds and structured export outputs for issue tracking.</a:t>
+            </a:r>
+          </a:p>
+        </p:txBody>
+      </p:sp>
     </p:spTree>
   </p:cSld>
   <p:clrMapOvr>
@@ -3458,14 +3525,6 @@
 <file path=ppt/slides/slide4.xml><?xml version="1.0" encoding="utf-8"?>
 <p:sld xmlns:a="http://schemas.openxmlformats.org/drawingml/2006/main" xmlns:p="http://schemas.openxmlformats.org/presentationml/2006/main" xmlns:r="http://schemas.openxmlformats.org/officeDocument/2006/relationships">
   <p:cSld>
-    <p:bg>
-      <p:bgPr>
-        <a:solidFill>
-          <a:srgbClr val="172554"/>
-        </a:solidFill>
-        <a:effectLst/>
-      </p:bgPr>
-    </p:bg>
     <p:spTree>
       <p:nvGrpSpPr>
         <p:cNvPr id="1" name=""/>
@@ -3475,14 +3534,57 @@
       <p:grpSpPr/>
       <p:sp>
         <p:nvSpPr>
-          <p:cNvPr id="2" name="TextBox 1"/>
+          <p:cNvPr id="2" name="Rectangle 1"/>
+          <p:cNvSpPr/>
+          <p:nvPr/>
+        </p:nvSpPr>
+        <p:spPr>
+          <a:xfrm>
+            <a:off x="0" y="0"/>
+            <a:ext cx="12191695" cy="1005840"/>
+          </a:xfrm>
+          <a:prstGeom prst="rect">
+            <a:avLst/>
+          </a:prstGeom>
+          <a:solidFill>
+            <a:srgbClr val="0D1B2A"/>
+          </a:solidFill>
+          <a:ln>
+            <a:noFill/>
+          </a:ln>
+        </p:spPr>
+        <p:style>
+          <a:lnRef idx="1">
+            <a:schemeClr val="accent1"/>
+          </a:lnRef>
+          <a:fillRef idx="3">
+            <a:schemeClr val="accent1"/>
+          </a:fillRef>
+          <a:effectRef idx="2">
+            <a:schemeClr val="accent1"/>
+          </a:effectRef>
+          <a:fontRef idx="minor">
+            <a:schemeClr val="lt1"/>
+          </a:fontRef>
+        </p:style>
+        <p:txBody>
+          <a:bodyPr rtlCol="0" anchor="ctr"/>
+          <a:lstStyle/>
+          <a:p>
+            <a:pPr algn="ctr"/>
+          </a:p>
+        </p:txBody>
+      </p:sp>
+      <p:sp>
+        <p:nvSpPr>
+          <p:cNvPr id="3" name="TextBox 2"/>
           <p:cNvSpPr txBox="1"/>
           <p:nvPr/>
         </p:nvSpPr>
         <p:spPr>
           <a:xfrm>
-            <a:off x="457200" y="228600"/>
-            <a:ext cx="11247120" cy="822960"/>
+            <a:off x="548640" y="228600"/>
+            <a:ext cx="11155680" cy="548640"/>
           </a:xfrm>
           <a:prstGeom prst="rect">
             <a:avLst/>
@@ -3496,125 +3598,411 @@
           <a:lstStyle/>
           <a:p>
             <a:pPr>
-              <a:defRPr sz="3600" b="1">
+              <a:defRPr sz="2800" b="1">
                 <a:solidFill>
-                  <a:srgbClr val="93C5FD"/>
+                  <a:srgbClr val="FFFFFF"/>
                 </a:solidFill>
               </a:defRPr>
             </a:pPr>
             <a:r>
-              <a:t>3) Tools for Fellow Engineers</a:t>
-            </a:r>
-          </a:p>
-        </p:txBody>
-      </p:sp>
-      <p:sp>
-        <p:nvSpPr>
-          <p:cNvPr id="3" name="TextBox 2"/>
-          <p:cNvSpPr txBox="1"/>
+              <a:t>Analysis Workflow</a:t>
+            </a:r>
+          </a:p>
+        </p:txBody>
+      </p:sp>
+      <p:sp>
+        <p:nvSpPr>
+          <p:cNvPr id="4" name="Rectangle 3"/>
+          <p:cNvSpPr/>
           <p:nvPr/>
         </p:nvSpPr>
         <p:spPr>
           <a:xfrm>
-            <a:off x="731520" y="1280160"/>
-            <a:ext cx="5669280" cy="4389120"/>
+            <a:off x="640080" y="2103120"/>
+            <a:ext cx="2651760" cy="1828800"/>
           </a:xfrm>
           <a:prstGeom prst="rect">
             <a:avLst/>
           </a:prstGeom>
-          <a:noFill/>
+          <a:solidFill>
+            <a:srgbClr val="EBF2F9"/>
+          </a:solidFill>
+          <a:ln>
+            <a:solidFill>
+              <a:srgbClr val="1E6FA8"/>
+            </a:solidFill>
+          </a:ln>
         </p:spPr>
-        <p:txBody>
-          <a:bodyPr wrap="none">
-            <a:spAutoFit/>
-          </a:bodyPr>
-          <a:lstStyle/>
-          <a:p>
-            <a:pPr>
-              <a:defRPr sz="2200">
+        <p:style>
+          <a:lnRef idx="1">
+            <a:schemeClr val="accent1"/>
+          </a:lnRef>
+          <a:fillRef idx="3">
+            <a:schemeClr val="accent1"/>
+          </a:fillRef>
+          <a:effectRef idx="2">
+            <a:schemeClr val="accent1"/>
+          </a:effectRef>
+          <a:fontRef idx="minor">
+            <a:schemeClr val="lt1"/>
+          </a:fontRef>
+        </p:style>
+        <p:txBody>
+          <a:bodyPr rtlCol="0" anchor="ctr"/>
+          <a:lstStyle/>
+          <a:p>
+            <a:pPr algn="ctr">
+              <a:defRPr b="1" sz="1800">
                 <a:solidFill>
-                  <a:srgbClr val="DBEAFE"/>
+                  <a:srgbClr val="0D1B2A"/>
                 </a:solidFill>
               </a:defRPr>
             </a:pPr>
             <a:r>
-              <a:t>• KeyOffLoad_Diagnostic_Tool.html (no install, works offline)</a:t>
+              <a:t>1. Load Log</a:t>
             </a:r>
           </a:p>
           <a:p>
             <a:pPr>
-              <a:defRPr sz="2200">
+              <a:defRPr sz="1300">
                 <a:solidFill>
-                  <a:srgbClr val="DBEAFE"/>
+                  <a:srgbClr val="465462"/>
                 </a:solidFill>
               </a:defRPr>
             </a:pPr>
             <a:r>
-              <a:t>• test_data/ with complex scenarios (normal, violations, stress)</a:t>
-            </a:r>
-          </a:p>
-          <a:p>
-            <a:pPr>
-              <a:defRPr sz="2200">
-                <a:solidFill>
-                  <a:srgbClr val="DBEAFE"/>
-                </a:solidFill>
-              </a:defRPr>
-            </a:pPr>
-            <a:r>
-              <a:t>• OUTPUT_ANALYSIS_GUIDE.md (how to read and triage output)</a:t>
-            </a:r>
-          </a:p>
-          <a:p>
-            <a:pPr>
-              <a:defRPr sz="2200">
-                <a:solidFill>
-                  <a:srgbClr val="DBEAFE"/>
-                </a:solidFill>
-              </a:defRPr>
-            </a:pPr>
-            <a:r>
-              <a:t>• Export options: CSV / JSON / Print report for issue tracking</a:t>
-            </a:r>
-          </a:p>
-          <a:p>
-            <a:pPr>
-              <a:defRPr sz="2200">
-                <a:solidFill>
-                  <a:srgbClr val="DBEAFE"/>
-                </a:solidFill>
-              </a:defRPr>
-            </a:pPr>
-            <a:r>
-              <a:t>• Existing KeyOffLoad_Presentation.pptx for technical review</a:t>
-            </a:r>
-          </a:p>
-        </p:txBody>
-      </p:sp>
-      <p:pic>
-        <p:nvPicPr>
-          <p:cNvPr id="4" name="Picture 3" descr="dashboard_visual.png"/>
-          <p:cNvPicPr>
-            <a:picLocks noChangeAspect="1"/>
-          </p:cNvPicPr>
+              <a:t>ASC / CSV / TXT</a:t>
+            </a:r>
+          </a:p>
+        </p:txBody>
+      </p:sp>
+      <p:sp>
+        <p:nvSpPr>
+          <p:cNvPr id="5" name="Can 4"/>
+          <p:cNvSpPr/>
           <p:nvPr/>
-        </p:nvPicPr>
-        <p:blipFill>
-          <a:blip r:embed="rId2"/>
-          <a:stretch>
-            <a:fillRect/>
-          </a:stretch>
-        </p:blipFill>
+        </p:nvSpPr>
         <p:spPr>
           <a:xfrm>
-            <a:off x="6400800" y="1463040"/>
-            <a:ext cx="5212080" cy="4389120"/>
+            <a:off x="3337560" y="2788920"/>
+            <a:ext cx="502920" cy="411480"/>
+          </a:xfrm>
+          <a:prstGeom prst="can">
+            <a:avLst/>
+          </a:prstGeom>
+          <a:solidFill>
+            <a:srgbClr val="1E6FA8"/>
+          </a:solidFill>
+          <a:ln>
+            <a:noFill/>
+          </a:ln>
+        </p:spPr>
+        <p:style>
+          <a:lnRef idx="1">
+            <a:schemeClr val="accent1"/>
+          </a:lnRef>
+          <a:fillRef idx="3">
+            <a:schemeClr val="accent1"/>
+          </a:fillRef>
+          <a:effectRef idx="2">
+            <a:schemeClr val="accent1"/>
+          </a:effectRef>
+          <a:fontRef idx="minor">
+            <a:schemeClr val="lt1"/>
+          </a:fontRef>
+        </p:style>
+        <p:txBody>
+          <a:bodyPr rtlCol="0" anchor="ctr"/>
+          <a:lstStyle/>
+          <a:p>
+            <a:pPr algn="ctr"/>
+          </a:p>
+        </p:txBody>
+      </p:sp>
+      <p:sp>
+        <p:nvSpPr>
+          <p:cNvPr id="6" name="Rectangle 5"/>
+          <p:cNvSpPr/>
+          <p:nvPr/>
+        </p:nvSpPr>
+        <p:spPr>
+          <a:xfrm>
+            <a:off x="3520439" y="2103120"/>
+            <a:ext cx="2651760" cy="1828800"/>
           </a:xfrm>
           <a:prstGeom prst="rect">
             <a:avLst/>
           </a:prstGeom>
+          <a:solidFill>
+            <a:srgbClr val="EBF2F9"/>
+          </a:solidFill>
+          <a:ln>
+            <a:solidFill>
+              <a:srgbClr val="1E6FA8"/>
+            </a:solidFill>
+          </a:ln>
         </p:spPr>
-      </p:pic>
+        <p:style>
+          <a:lnRef idx="1">
+            <a:schemeClr val="accent1"/>
+          </a:lnRef>
+          <a:fillRef idx="3">
+            <a:schemeClr val="accent1"/>
+          </a:fillRef>
+          <a:effectRef idx="2">
+            <a:schemeClr val="accent1"/>
+          </a:effectRef>
+          <a:fontRef idx="minor">
+            <a:schemeClr val="lt1"/>
+          </a:fontRef>
+        </p:style>
+        <p:txBody>
+          <a:bodyPr rtlCol="0" anchor="ctr"/>
+          <a:lstStyle/>
+          <a:p>
+            <a:pPr algn="ctr">
+              <a:defRPr b="1" sz="1800">
+                <a:solidFill>
+                  <a:srgbClr val="0D1B2A"/>
+                </a:solidFill>
+              </a:defRPr>
+            </a:pPr>
+            <a:r>
+              <a:t>2. Configure</a:t>
+            </a:r>
+          </a:p>
+          <a:p>
+            <a:pPr>
+              <a:defRPr sz="1300">
+                <a:solidFill>
+                  <a:srgbClr val="465462"/>
+                </a:solidFill>
+              </a:defRPr>
+            </a:pPr>
+            <a:r>
+              <a:t>Key-off + thresholds</a:t>
+            </a:r>
+          </a:p>
+        </p:txBody>
+      </p:sp>
+      <p:sp>
+        <p:nvSpPr>
+          <p:cNvPr id="7" name="Can 6"/>
+          <p:cNvSpPr/>
+          <p:nvPr/>
+        </p:nvSpPr>
+        <p:spPr>
+          <a:xfrm>
+            <a:off x="6217920" y="2788920"/>
+            <a:ext cx="502920" cy="411480"/>
+          </a:xfrm>
+          <a:prstGeom prst="can">
+            <a:avLst/>
+          </a:prstGeom>
+          <a:solidFill>
+            <a:srgbClr val="1E6FA8"/>
+          </a:solidFill>
+          <a:ln>
+            <a:noFill/>
+          </a:ln>
+        </p:spPr>
+        <p:style>
+          <a:lnRef idx="1">
+            <a:schemeClr val="accent1"/>
+          </a:lnRef>
+          <a:fillRef idx="3">
+            <a:schemeClr val="accent1"/>
+          </a:fillRef>
+          <a:effectRef idx="2">
+            <a:schemeClr val="accent1"/>
+          </a:effectRef>
+          <a:fontRef idx="minor">
+            <a:schemeClr val="lt1"/>
+          </a:fontRef>
+        </p:style>
+        <p:txBody>
+          <a:bodyPr rtlCol="0" anchor="ctr"/>
+          <a:lstStyle/>
+          <a:p>
+            <a:pPr algn="ctr"/>
+          </a:p>
+        </p:txBody>
+      </p:sp>
+      <p:sp>
+        <p:nvSpPr>
+          <p:cNvPr id="8" name="Rectangle 7"/>
+          <p:cNvSpPr/>
+          <p:nvPr/>
+        </p:nvSpPr>
+        <p:spPr>
+          <a:xfrm>
+            <a:off x="6400800" y="2103120"/>
+            <a:ext cx="2651760" cy="1828800"/>
+          </a:xfrm>
+          <a:prstGeom prst="rect">
+            <a:avLst/>
+          </a:prstGeom>
+          <a:solidFill>
+            <a:srgbClr val="EBF2F9"/>
+          </a:solidFill>
+          <a:ln>
+            <a:solidFill>
+              <a:srgbClr val="1E6FA8"/>
+            </a:solidFill>
+          </a:ln>
+        </p:spPr>
+        <p:style>
+          <a:lnRef idx="1">
+            <a:schemeClr val="accent1"/>
+          </a:lnRef>
+          <a:fillRef idx="3">
+            <a:schemeClr val="accent1"/>
+          </a:fillRef>
+          <a:effectRef idx="2">
+            <a:schemeClr val="accent1"/>
+          </a:effectRef>
+          <a:fontRef idx="minor">
+            <a:schemeClr val="lt1"/>
+          </a:fontRef>
+        </p:style>
+        <p:txBody>
+          <a:bodyPr rtlCol="0" anchor="ctr"/>
+          <a:lstStyle/>
+          <a:p>
+            <a:pPr algn="ctr">
+              <a:defRPr b="1" sz="1800">
+                <a:solidFill>
+                  <a:srgbClr val="0D1B2A"/>
+                </a:solidFill>
+              </a:defRPr>
+            </a:pPr>
+            <a:r>
+              <a:t>3. Analyse</a:t>
+            </a:r>
+          </a:p>
+          <a:p>
+            <a:pPr>
+              <a:defRPr sz="1300">
+                <a:solidFill>
+                  <a:srgbClr val="465462"/>
+                </a:solidFill>
+              </a:defRPr>
+            </a:pPr>
+            <a:r>
+              <a:t>Auto ECU classification</a:t>
+            </a:r>
+          </a:p>
+        </p:txBody>
+      </p:sp>
+      <p:sp>
+        <p:nvSpPr>
+          <p:cNvPr id="9" name="Can 8"/>
+          <p:cNvSpPr/>
+          <p:nvPr/>
+        </p:nvSpPr>
+        <p:spPr>
+          <a:xfrm>
+            <a:off x="9098280" y="2788920"/>
+            <a:ext cx="502920" cy="411480"/>
+          </a:xfrm>
+          <a:prstGeom prst="can">
+            <a:avLst/>
+          </a:prstGeom>
+          <a:solidFill>
+            <a:srgbClr val="1E6FA8"/>
+          </a:solidFill>
+          <a:ln>
+            <a:noFill/>
+          </a:ln>
+        </p:spPr>
+        <p:style>
+          <a:lnRef idx="1">
+            <a:schemeClr val="accent1"/>
+          </a:lnRef>
+          <a:fillRef idx="3">
+            <a:schemeClr val="accent1"/>
+          </a:fillRef>
+          <a:effectRef idx="2">
+            <a:schemeClr val="accent1"/>
+          </a:effectRef>
+          <a:fontRef idx="minor">
+            <a:schemeClr val="lt1"/>
+          </a:fontRef>
+        </p:style>
+        <p:txBody>
+          <a:bodyPr rtlCol="0" anchor="ctr"/>
+          <a:lstStyle/>
+          <a:p>
+            <a:pPr algn="ctr"/>
+          </a:p>
+        </p:txBody>
+      </p:sp>
+      <p:sp>
+        <p:nvSpPr>
+          <p:cNvPr id="10" name="Rectangle 9"/>
+          <p:cNvSpPr/>
+          <p:nvPr/>
+        </p:nvSpPr>
+        <p:spPr>
+          <a:xfrm>
+            <a:off x="9281160" y="2103120"/>
+            <a:ext cx="2651760" cy="1828800"/>
+          </a:xfrm>
+          <a:prstGeom prst="rect">
+            <a:avLst/>
+          </a:prstGeom>
+          <a:solidFill>
+            <a:srgbClr val="EBF2F9"/>
+          </a:solidFill>
+          <a:ln>
+            <a:solidFill>
+              <a:srgbClr val="1E6FA8"/>
+            </a:solidFill>
+          </a:ln>
+        </p:spPr>
+        <p:style>
+          <a:lnRef idx="1">
+            <a:schemeClr val="accent1"/>
+          </a:lnRef>
+          <a:fillRef idx="3">
+            <a:schemeClr val="accent1"/>
+          </a:fillRef>
+          <a:effectRef idx="2">
+            <a:schemeClr val="accent1"/>
+          </a:effectRef>
+          <a:fontRef idx="minor">
+            <a:schemeClr val="lt1"/>
+          </a:fontRef>
+        </p:style>
+        <p:txBody>
+          <a:bodyPr rtlCol="0" anchor="ctr"/>
+          <a:lstStyle/>
+          <a:p>
+            <a:pPr algn="ctr">
+              <a:defRPr b="1" sz="1800">
+                <a:solidFill>
+                  <a:srgbClr val="0D1B2A"/>
+                </a:solidFill>
+              </a:defRPr>
+            </a:pPr>
+            <a:r>
+              <a:t>4. Report</a:t>
+            </a:r>
+          </a:p>
+          <a:p>
+            <a:pPr>
+              <a:defRPr sz="1300">
+                <a:solidFill>
+                  <a:srgbClr val="465462"/>
+                </a:solidFill>
+              </a:defRPr>
+            </a:pPr>
+            <a:r>
+              <a:t>Review + export output</a:t>
+            </a:r>
+          </a:p>
+        </p:txBody>
+      </p:sp>
     </p:spTree>
   </p:cSld>
   <p:clrMapOvr>
@@ -3626,14 +4014,6 @@
 <file path=ppt/slides/slide5.xml><?xml version="1.0" encoding="utf-8"?>
 <p:sld xmlns:a="http://schemas.openxmlformats.org/drawingml/2006/main" xmlns:p="http://schemas.openxmlformats.org/presentationml/2006/main" xmlns:r="http://schemas.openxmlformats.org/officeDocument/2006/relationships">
   <p:cSld>
-    <p:bg>
-      <p:bgPr>
-        <a:solidFill>
-          <a:srgbClr val="3F0D12"/>
-        </a:solidFill>
-        <a:effectLst/>
-      </p:bgPr>
-    </p:bg>
     <p:spTree>
       <p:nvGrpSpPr>
         <p:cNvPr id="1" name=""/>
@@ -3643,14 +4023,57 @@
       <p:grpSpPr/>
       <p:sp>
         <p:nvSpPr>
-          <p:cNvPr id="2" name="TextBox 1"/>
+          <p:cNvPr id="2" name="Rectangle 1"/>
+          <p:cNvSpPr/>
+          <p:nvPr/>
+        </p:nvSpPr>
+        <p:spPr>
+          <a:xfrm>
+            <a:off x="0" y="0"/>
+            <a:ext cx="12191695" cy="1005840"/>
+          </a:xfrm>
+          <a:prstGeom prst="rect">
+            <a:avLst/>
+          </a:prstGeom>
+          <a:solidFill>
+            <a:srgbClr val="0D1B2A"/>
+          </a:solidFill>
+          <a:ln>
+            <a:noFill/>
+          </a:ln>
+        </p:spPr>
+        <p:style>
+          <a:lnRef idx="1">
+            <a:schemeClr val="accent1"/>
+          </a:lnRef>
+          <a:fillRef idx="3">
+            <a:schemeClr val="accent1"/>
+          </a:fillRef>
+          <a:effectRef idx="2">
+            <a:schemeClr val="accent1"/>
+          </a:effectRef>
+          <a:fontRef idx="minor">
+            <a:schemeClr val="lt1"/>
+          </a:fontRef>
+        </p:style>
+        <p:txBody>
+          <a:bodyPr rtlCol="0" anchor="ctr"/>
+          <a:lstStyle/>
+          <a:p>
+            <a:pPr algn="ctr"/>
+          </a:p>
+        </p:txBody>
+      </p:sp>
+      <p:sp>
+        <p:nvSpPr>
+          <p:cNvPr id="3" name="TextBox 2"/>
           <p:cNvSpPr txBox="1"/>
           <p:nvPr/>
         </p:nvSpPr>
         <p:spPr>
           <a:xfrm>
-            <a:off x="457200" y="228600"/>
-            <a:ext cx="11247120" cy="822960"/>
+            <a:off x="548640" y="228600"/>
+            <a:ext cx="11155680" cy="548640"/>
           </a:xfrm>
           <a:prstGeom prst="rect">
             <a:avLst/>
@@ -3664,15 +4087,588 @@
           <a:lstStyle/>
           <a:p>
             <a:pPr>
-              <a:defRPr sz="3600" b="1">
+              <a:defRPr sz="2600" b="1">
                 <a:solidFill>
-                  <a:srgbClr val="FCA5A5"/>
+                  <a:srgbClr val="FFFFFF"/>
                 </a:solidFill>
               </a:defRPr>
             </a:pPr>
             <a:r>
-              <a:t>4) Presentation Showcase</a:t>
-            </a:r>
+              <a:t>Validation Dataset Coverage</a:t>
+            </a:r>
+          </a:p>
+        </p:txBody>
+      </p:sp>
+      <p:graphicFrame>
+        <p:nvGraphicFramePr>
+          <p:cNvPr id="4" name="Table 3"/>
+          <p:cNvGraphicFramePr>
+            <a:graphicFrameLocks noGrp="1"/>
+          </p:cNvGraphicFramePr>
+          <p:nvPr/>
+        </p:nvGraphicFramePr>
+        <p:xfrm>
+          <a:off x="548640" y="1371600"/>
+          <a:ext cx="11064240" cy="5120640"/>
+        </p:xfrm>
+        <a:graphic>
+          <a:graphicData uri="http://schemas.openxmlformats.org/drawingml/2006/table">
+            <a:tbl>
+              <a:tblPr firstRow="1" bandRow="1">
+                <a:tableStyleId>{5C22544A-7EE6-4342-B048-85BDC9FD1C3A}</a:tableStyleId>
+              </a:tblPr>
+              <a:tblGrid>
+                <a:gridCol w="2766060"/>
+                <a:gridCol w="2766060"/>
+                <a:gridCol w="2766060"/>
+                <a:gridCol w="2766060"/>
+              </a:tblGrid>
+              <a:tr h="853440">
+                <a:tc>
+                  <a:txBody>
+                    <a:bodyPr/>
+                    <a:lstStyle/>
+                    <a:p>
+                      <a:pPr>
+                        <a:defRPr b="1" sz="1400">
+                          <a:solidFill>
+                            <a:srgbClr val="FFFFFF"/>
+                          </a:solidFill>
+                        </a:defRPr>
+                      </a:pPr>
+                      <a:r>
+                        <a:t>File</a:t>
+                      </a:r>
+                    </a:p>
+                  </a:txBody>
+                  <a:tcPr>
+                    <a:solidFill>
+                      <a:srgbClr val="1E6FA8"/>
+                    </a:solidFill>
+                  </a:tcPr>
+                </a:tc>
+                <a:tc>
+                  <a:txBody>
+                    <a:bodyPr/>
+                    <a:lstStyle/>
+                    <a:p>
+                      <a:pPr>
+                        <a:defRPr b="1" sz="1400">
+                          <a:solidFill>
+                            <a:srgbClr val="FFFFFF"/>
+                          </a:solidFill>
+                        </a:defRPr>
+                      </a:pPr>
+                      <a:r>
+                        <a:t>ECUs</a:t>
+                      </a:r>
+                    </a:p>
+                  </a:txBody>
+                  <a:tcPr>
+                    <a:solidFill>
+                      <a:srgbClr val="1E6FA8"/>
+                    </a:solidFill>
+                  </a:tcPr>
+                </a:tc>
+                <a:tc>
+                  <a:txBody>
+                    <a:bodyPr/>
+                    <a:lstStyle/>
+                    <a:p>
+                      <a:pPr>
+                        <a:defRPr b="1" sz="1400">
+                          <a:solidFill>
+                            <a:srgbClr val="FFFFFF"/>
+                          </a:solidFill>
+                        </a:defRPr>
+                      </a:pPr>
+                      <a:r>
+                        <a:t>Scenario</a:t>
+                      </a:r>
+                    </a:p>
+                  </a:txBody>
+                  <a:tcPr>
+                    <a:solidFill>
+                      <a:srgbClr val="1E6FA8"/>
+                    </a:solidFill>
+                  </a:tcPr>
+                </a:tc>
+                <a:tc>
+                  <a:txBody>
+                    <a:bodyPr/>
+                    <a:lstStyle/>
+                    <a:p>
+                      <a:pPr>
+                        <a:defRPr b="1" sz="1400">
+                          <a:solidFill>
+                            <a:srgbClr val="FFFFFF"/>
+                          </a:solidFill>
+                        </a:defRPr>
+                      </a:pPr>
+                      <a:r>
+                        <a:t>Expected</a:t>
+                      </a:r>
+                    </a:p>
+                  </a:txBody>
+                  <a:tcPr>
+                    <a:solidFill>
+                      <a:srgbClr val="1E6FA8"/>
+                    </a:solidFill>
+                  </a:tcPr>
+                </a:tc>
+              </a:tr>
+              <a:tr h="853440">
+                <a:tc>
+                  <a:txBody>
+                    <a:bodyPr/>
+                    <a:lstStyle/>
+                    <a:p>
+                      <a:pPr>
+                        <a:defRPr sz="1200">
+                          <a:solidFill>
+                            <a:srgbClr val="465462"/>
+                          </a:solidFill>
+                        </a:defRPr>
+                      </a:pPr>
+                      <a:r>
+                        <a:t>01_normal_shutdown_PASS.csv</a:t>
+                      </a:r>
+                    </a:p>
+                  </a:txBody>
+                  <a:tcPr/>
+                </a:tc>
+                <a:tc>
+                  <a:txBody>
+                    <a:bodyPr/>
+                    <a:lstStyle/>
+                    <a:p>
+                      <a:pPr>
+                        <a:defRPr sz="1200">
+                          <a:solidFill>
+                            <a:srgbClr val="465462"/>
+                          </a:solidFill>
+                        </a:defRPr>
+                      </a:pPr>
+                      <a:r>
+                        <a:t>8</a:t>
+                      </a:r>
+                    </a:p>
+                  </a:txBody>
+                  <a:tcPr/>
+                </a:tc>
+                <a:tc>
+                  <a:txBody>
+                    <a:bodyPr/>
+                    <a:lstStyle/>
+                    <a:p>
+                      <a:pPr>
+                        <a:defRPr sz="1200">
+                          <a:solidFill>
+                            <a:srgbClr val="465462"/>
+                          </a:solidFill>
+                        </a:defRPr>
+                      </a:pPr>
+                      <a:r>
+                        <a:t>Baseline</a:t>
+                      </a:r>
+                    </a:p>
+                  </a:txBody>
+                  <a:tcPr/>
+                </a:tc>
+                <a:tc>
+                  <a:txBody>
+                    <a:bodyPr/>
+                    <a:lstStyle/>
+                    <a:p>
+                      <a:pPr>
+                        <a:defRPr sz="1200">
+                          <a:solidFill>
+                            <a:srgbClr val="465462"/>
+                          </a:solidFill>
+                        </a:defRPr>
+                      </a:pPr>
+                      <a:r>
+                        <a:t>0 violations</a:t>
+                      </a:r>
+                    </a:p>
+                  </a:txBody>
+                  <a:tcPr/>
+                </a:tc>
+              </a:tr>
+              <a:tr h="853440">
+                <a:tc>
+                  <a:txBody>
+                    <a:bodyPr/>
+                    <a:lstStyle/>
+                    <a:p>
+                      <a:pPr>
+                        <a:defRPr sz="1200">
+                          <a:solidFill>
+                            <a:srgbClr val="465462"/>
+                          </a:solidFill>
+                        </a:defRPr>
+                      </a:pPr>
+                      <a:r>
+                        <a:t>02_multiple_violators_FAIL.csv</a:t>
+                      </a:r>
+                    </a:p>
+                  </a:txBody>
+                  <a:tcPr/>
+                </a:tc>
+                <a:tc>
+                  <a:txBody>
+                    <a:bodyPr/>
+                    <a:lstStyle/>
+                    <a:p>
+                      <a:pPr>
+                        <a:defRPr sz="1200">
+                          <a:solidFill>
+                            <a:srgbClr val="465462"/>
+                          </a:solidFill>
+                        </a:defRPr>
+                      </a:pPr>
+                      <a:r>
+                        <a:t>15</a:t>
+                      </a:r>
+                    </a:p>
+                  </a:txBody>
+                  <a:tcPr/>
+                </a:tc>
+                <a:tc>
+                  <a:txBody>
+                    <a:bodyPr/>
+                    <a:lstStyle/>
+                    <a:p>
+                      <a:pPr>
+                        <a:defRPr sz="1200">
+                          <a:solidFill>
+                            <a:srgbClr val="465462"/>
+                          </a:solidFill>
+                        </a:defRPr>
+                      </a:pPr>
+                      <a:r>
+                        <a:t>Mixed failures</a:t>
+                      </a:r>
+                    </a:p>
+                  </a:txBody>
+                  <a:tcPr/>
+                </a:tc>
+                <a:tc>
+                  <a:txBody>
+                    <a:bodyPr/>
+                    <a:lstStyle/>
+                    <a:p>
+                      <a:pPr>
+                        <a:defRPr sz="1200">
+                          <a:solidFill>
+                            <a:srgbClr val="465462"/>
+                          </a:solidFill>
+                        </a:defRPr>
+                      </a:pPr>
+                      <a:r>
+                        <a:t>7 violations</a:t>
+                      </a:r>
+                    </a:p>
+                  </a:txBody>
+                  <a:tcPr/>
+                </a:tc>
+              </a:tr>
+              <a:tr h="853440">
+                <a:tc>
+                  <a:txBody>
+                    <a:bodyPr/>
+                    <a:lstStyle/>
+                    <a:p>
+                      <a:pPr>
+                        <a:defRPr sz="1200">
+                          <a:solidFill>
+                            <a:srgbClr val="465462"/>
+                          </a:solidFill>
+                        </a:defRPr>
+                      </a:pPr>
+                      <a:r>
+                        <a:t>03_vector_asc_format.asc</a:t>
+                      </a:r>
+                    </a:p>
+                  </a:txBody>
+                  <a:tcPr/>
+                </a:tc>
+                <a:tc>
+                  <a:txBody>
+                    <a:bodyPr/>
+                    <a:lstStyle/>
+                    <a:p>
+                      <a:pPr>
+                        <a:defRPr sz="1200">
+                          <a:solidFill>
+                            <a:srgbClr val="465462"/>
+                          </a:solidFill>
+                        </a:defRPr>
+                      </a:pPr>
+                      <a:r>
+                        <a:t>8</a:t>
+                      </a:r>
+                    </a:p>
+                  </a:txBody>
+                  <a:tcPr/>
+                </a:tc>
+                <a:tc>
+                  <a:txBody>
+                    <a:bodyPr/>
+                    <a:lstStyle/>
+                    <a:p>
+                      <a:pPr>
+                        <a:defRPr sz="1200">
+                          <a:solidFill>
+                            <a:srgbClr val="465462"/>
+                          </a:solidFill>
+                        </a:defRPr>
+                      </a:pPr>
+                      <a:r>
+                        <a:t>Vector ASC</a:t>
+                      </a:r>
+                    </a:p>
+                  </a:txBody>
+                  <a:tcPr/>
+                </a:tc>
+                <a:tc>
+                  <a:txBody>
+                    <a:bodyPr/>
+                    <a:lstStyle/>
+                    <a:p>
+                      <a:pPr>
+                        <a:defRPr sz="1200">
+                          <a:solidFill>
+                            <a:srgbClr val="465462"/>
+                          </a:solidFill>
+                        </a:defRPr>
+                      </a:pPr>
+                      <a:r>
+                        <a:t>2 stuck ECUs</a:t>
+                      </a:r>
+                    </a:p>
+                  </a:txBody>
+                  <a:tcPr/>
+                </a:tc>
+              </a:tr>
+              <a:tr h="853440">
+                <a:tc>
+                  <a:txBody>
+                    <a:bodyPr/>
+                    <a:lstStyle/>
+                    <a:p>
+                      <a:pPr>
+                        <a:defRPr sz="1200">
+                          <a:solidFill>
+                            <a:srgbClr val="465462"/>
+                          </a:solidFill>
+                        </a:defRPr>
+                      </a:pPr>
+                      <a:r>
+                        <a:t>05_realworld_complex_25ECUs.csv</a:t>
+                      </a:r>
+                    </a:p>
+                  </a:txBody>
+                  <a:tcPr/>
+                </a:tc>
+                <a:tc>
+                  <a:txBody>
+                    <a:bodyPr/>
+                    <a:lstStyle/>
+                    <a:p>
+                      <a:pPr>
+                        <a:defRPr sz="1200">
+                          <a:solidFill>
+                            <a:srgbClr val="465462"/>
+                          </a:solidFill>
+                        </a:defRPr>
+                      </a:pPr>
+                      <a:r>
+                        <a:t>25</a:t>
+                      </a:r>
+                    </a:p>
+                  </a:txBody>
+                  <a:tcPr/>
+                </a:tc>
+                <a:tc>
+                  <a:txBody>
+                    <a:bodyPr/>
+                    <a:lstStyle/>
+                    <a:p>
+                      <a:pPr>
+                        <a:defRPr sz="1200">
+                          <a:solidFill>
+                            <a:srgbClr val="465462"/>
+                          </a:solidFill>
+                        </a:defRPr>
+                      </a:pPr>
+                      <a:r>
+                        <a:t>Vehicle-scale</a:t>
+                      </a:r>
+                    </a:p>
+                  </a:txBody>
+                  <a:tcPr/>
+                </a:tc>
+                <a:tc>
+                  <a:txBody>
+                    <a:bodyPr/>
+                    <a:lstStyle/>
+                    <a:p>
+                      <a:pPr>
+                        <a:defRPr sz="1200">
+                          <a:solidFill>
+                            <a:srgbClr val="465462"/>
+                          </a:solidFill>
+                        </a:defRPr>
+                      </a:pPr>
+                      <a:r>
+                        <a:t>8 violations</a:t>
+                      </a:r>
+                    </a:p>
+                  </a:txBody>
+                  <a:tcPr/>
+                </a:tc>
+              </a:tr>
+              <a:tr h="853440">
+                <a:tc>
+                  <a:txBody>
+                    <a:bodyPr/>
+                    <a:lstStyle/>
+                    <a:p>
+                      <a:pPr>
+                        <a:defRPr sz="1200">
+                          <a:solidFill>
+                            <a:srgbClr val="465462"/>
+                          </a:solidFill>
+                        </a:defRPr>
+                      </a:pPr>
+                      <a:r>
+                        <a:t>06_stress_test_50ECUs.csv</a:t>
+                      </a:r>
+                    </a:p>
+                  </a:txBody>
+                  <a:tcPr/>
+                </a:tc>
+                <a:tc>
+                  <a:txBody>
+                    <a:bodyPr/>
+                    <a:lstStyle/>
+                    <a:p>
+                      <a:pPr>
+                        <a:defRPr sz="1200">
+                          <a:solidFill>
+                            <a:srgbClr val="465462"/>
+                          </a:solidFill>
+                        </a:defRPr>
+                      </a:pPr>
+                      <a:r>
+                        <a:t>50</a:t>
+                      </a:r>
+                    </a:p>
+                  </a:txBody>
+                  <a:tcPr/>
+                </a:tc>
+                <a:tc>
+                  <a:txBody>
+                    <a:bodyPr/>
+                    <a:lstStyle/>
+                    <a:p>
+                      <a:pPr>
+                        <a:defRPr sz="1200">
+                          <a:solidFill>
+                            <a:srgbClr val="465462"/>
+                          </a:solidFill>
+                        </a:defRPr>
+                      </a:pPr>
+                      <a:r>
+                        <a:t>Stress volume</a:t>
+                      </a:r>
+                    </a:p>
+                  </a:txBody>
+                  <a:tcPr/>
+                </a:tc>
+                <a:tc>
+                  <a:txBody>
+                    <a:bodyPr/>
+                    <a:lstStyle/>
+                    <a:p>
+                      <a:pPr>
+                        <a:defRPr sz="1200">
+                          <a:solidFill>
+                            <a:srgbClr val="465462"/>
+                          </a:solidFill>
+                        </a:defRPr>
+                      </a:pPr>
+                      <a:r>
+                        <a:t>15 violations</a:t>
+                      </a:r>
+                    </a:p>
+                  </a:txBody>
+                  <a:tcPr/>
+                </a:tc>
+              </a:tr>
+            </a:tbl>
+          </a:graphicData>
+        </a:graphic>
+      </p:graphicFrame>
+    </p:spTree>
+  </p:cSld>
+  <p:clrMapOvr>
+    <a:masterClrMapping/>
+  </p:clrMapOvr>
+</p:sld>
+</file>
+
+<file path=ppt/slides/slide6.xml><?xml version="1.0" encoding="utf-8"?>
+<p:sld xmlns:a="http://schemas.openxmlformats.org/drawingml/2006/main" xmlns:p="http://schemas.openxmlformats.org/presentationml/2006/main" xmlns:r="http://schemas.openxmlformats.org/officeDocument/2006/relationships">
+  <p:cSld>
+    <p:spTree>
+      <p:nvGrpSpPr>
+        <p:cNvPr id="1" name=""/>
+        <p:cNvGrpSpPr/>
+        <p:nvPr/>
+      </p:nvGrpSpPr>
+      <p:grpSpPr/>
+      <p:sp>
+        <p:nvSpPr>
+          <p:cNvPr id="2" name="Rectangle 1"/>
+          <p:cNvSpPr/>
+          <p:nvPr/>
+        </p:nvSpPr>
+        <p:spPr>
+          <a:xfrm>
+            <a:off x="0" y="0"/>
+            <a:ext cx="12191695" cy="1005840"/>
+          </a:xfrm>
+          <a:prstGeom prst="rect">
+            <a:avLst/>
+          </a:prstGeom>
+          <a:solidFill>
+            <a:srgbClr val="0D1B2A"/>
+          </a:solidFill>
+          <a:ln>
+            <a:noFill/>
+          </a:ln>
+        </p:spPr>
+        <p:style>
+          <a:lnRef idx="1">
+            <a:schemeClr val="accent1"/>
+          </a:lnRef>
+          <a:fillRef idx="3">
+            <a:schemeClr val="accent1"/>
+          </a:fillRef>
+          <a:effectRef idx="2">
+            <a:schemeClr val="accent1"/>
+          </a:effectRef>
+          <a:fontRef idx="minor">
+            <a:schemeClr val="lt1"/>
+          </a:fontRef>
+        </p:style>
+        <p:txBody>
+          <a:bodyPr rtlCol="0" anchor="ctr"/>
+          <a:lstStyle/>
+          <a:p>
+            <a:pPr algn="ctr"/>
           </a:p>
         </p:txBody>
       </p:sp>
@@ -3684,8 +4680,8 @@
         </p:nvSpPr>
         <p:spPr>
           <a:xfrm>
-            <a:off x="731520" y="1280160"/>
-            <a:ext cx="10972800" cy="4389120"/>
+            <a:off x="548640" y="228600"/>
+            <a:ext cx="11155680" cy="548640"/>
           </a:xfrm>
           <a:prstGeom prst="rect">
             <a:avLst/>
@@ -3699,62 +4695,82 @@
           <a:lstStyle/>
           <a:p>
             <a:pPr>
-              <a:defRPr sz="2500">
+              <a:defRPr sz="2800" b="1">
                 <a:solidFill>
-                  <a:srgbClr val="FEE2E2"/>
+                  <a:srgbClr val="FFFFFF"/>
                 </a:solidFill>
               </a:defRPr>
             </a:pPr>
             <a:r>
-              <a:t>• Open Expo One-Pager for quick audience overview</a:t>
-            </a:r>
-          </a:p>
+              <a:t>Delivery Package and Demo</a:t>
+            </a:r>
+          </a:p>
+        </p:txBody>
+      </p:sp>
+      <p:sp>
+        <p:nvSpPr>
+          <p:cNvPr id="4" name="TextBox 3"/>
+          <p:cNvSpPr txBox="1"/>
+          <p:nvPr/>
+        </p:nvSpPr>
+        <p:spPr>
+          <a:xfrm>
+            <a:off x="822960" y="1280160"/>
+            <a:ext cx="10789920" cy="5120640"/>
+          </a:xfrm>
+          <a:prstGeom prst="rect">
+            <a:avLst/>
+          </a:prstGeom>
+          <a:noFill/>
+        </p:spPr>
+        <p:txBody>
+          <a:bodyPr wrap="square">
+            <a:spAutoFit/>
+          </a:bodyPr>
+          <a:lstStyle/>
           <a:p>
             <a:pPr>
-              <a:defRPr sz="2500">
+              <a:spcAft>
+                <a:spcPts val="1400"/>
+              </a:spcAft>
+              <a:defRPr sz="2200">
                 <a:solidFill>
-                  <a:srgbClr val="FEE2E2"/>
+                  <a:srgbClr val="465462"/>
                 </a:solidFill>
               </a:defRPr>
             </a:pPr>
             <a:r>
-              <a:t>• Run live demo using stress-test dataset (50 ECUs)</a:t>
+              <a:t>Deliverables: KeyOffLoad_Diagnostic_Tool.html, Expo_OnePager.md, Expo_Showcase_Presentation.pptx.</a:t>
             </a:r>
           </a:p>
           <a:p>
             <a:pPr>
-              <a:defRPr sz="2500">
+              <a:spcAft>
+                <a:spcPts val="1400"/>
+              </a:spcAft>
+              <a:defRPr sz="2200">
                 <a:solidFill>
-                  <a:srgbClr val="FEE2E2"/>
+                  <a:srgbClr val="465462"/>
                 </a:solidFill>
               </a:defRPr>
             </a:pPr>
             <a:r>
-              <a:t>• Show timeline + violations to explain root-cause detection</a:t>
+              <a:t>Reference guide: OUTPUT_ANALYSIS_GUIDE.md with interpretation workflow and severity criteria.</a:t>
             </a:r>
           </a:p>
           <a:p>
             <a:pPr>
-              <a:defRPr sz="2500">
+              <a:spcAft>
+                <a:spcPts val="1400"/>
+              </a:spcAft>
+              <a:defRPr sz="2200">
                 <a:solidFill>
-                  <a:srgbClr val="FEE2E2"/>
+                  <a:srgbClr val="465462"/>
                 </a:solidFill>
               </a:defRPr>
             </a:pPr>
             <a:r>
-              <a:t>• Share downloadable HTML tool and PPT with attendees</a:t>
-            </a:r>
-          </a:p>
-          <a:p>
-            <a:pPr>
-              <a:defRPr sz="2500">
-                <a:solidFill>
-                  <a:srgbClr val="FEE2E2"/>
-                </a:solidFill>
-              </a:defRPr>
-            </a:pPr>
-            <a:r>
-              <a:t>• Key message: "Hours of manual analysis reduced to minutes"</a:t>
+              <a:t>Demo flow: Load dataset → Configure key-off time → Analyse → Review violations and export.</a:t>
             </a:r>
           </a:p>
         </p:txBody>

</xml_diff>